<commit_message>
Agenda change for Mahesh in session 2
</commit_message>
<xml_diff>
--- a/126/slides/slides-126-nmop-chair-slides-session2.pptx
+++ b/126/slides/slides-126-nmop-chair-slides-session2.pptx
@@ -10354,10 +10354,10 @@
       </p:sp>
       <p:pic>
         <p:nvPicPr>
-          <p:cNvPr id="7" name="Picture 6">
+          <p:cNvPr id="9" name="Picture 8">
             <a:extLst>
               <a:ext uri="{FF2B5EF4-FFF2-40B4-BE49-F238E27FC236}">
-                <a16:creationId xmlns:a16="http://schemas.microsoft.com/office/drawing/2014/main" id="{DD5A4910-A76A-65C2-3D27-A33C71FC9A39}"/>
+                <a16:creationId xmlns:a16="http://schemas.microsoft.com/office/drawing/2014/main" id="{FE217821-6792-BB6E-41A9-D0DECE09648C}"/>
               </a:ext>
             </a:extLst>
           </p:cNvPr>
@@ -10374,8 +10374,8 @@
         </p:blipFill>
         <p:spPr>
           <a:xfrm>
-            <a:off x="71560" y="1150996"/>
-            <a:ext cx="9005245" cy="2641776"/>
+            <a:off x="0" y="1101244"/>
+            <a:ext cx="7772400" cy="2824272"/>
           </a:xfrm>
           <a:prstGeom prst="rect">
             <a:avLst/>

</xml_diff>